<commit_message>
Align the deck's corpus figures with the repository
Slide 3 said '3,372 documents collected' while data/interim holds 5,898
and the workflow page says 5,898 collected / 3,372 analysed. Both the
deck and that page are submitted, so they cannot disagree about the size
of the corpus.

The stat is now labelled 'documents analysed', with the collected total
beside it and the footer stating which figure every number on the slide
describes. Nothing about the analysis changed -- 3,372 gated, 971
relevant, 937 extracted, 25 themes are the same numbers as before, and
they were always the analysed set.

Verified: 10 pages, validator clean, geometry check clean, slide 3
inspected at 105 dpi. MVP evals 11 pass 1 not run, and the workflow page
renders with no console errors and no horizontal overflow.

Co-Authored-By: Claude Opus 5 <noreply@anthropic.com>
Claude-Session: https://claude.ai/code/session_01FrFJdYU6272N5wv1HcTa3W
</commit_message>
<xml_diff>
--- a/deck/Blinkit-Category-Exploration.pptx
+++ b/deck/Blinkit-Category-Exploration.pptx
@@ -4620,7 +4620,7 @@
                 <a:ea typeface="Calibri" pitchFamily="34" charset="-122"/>
                 <a:cs typeface="Calibri" pitchFamily="34" charset="-120"/>
               </a:rPr>
-              <a:t>documents collected</a:t>
+              <a:t>documents analysed</a:t>
             </a:r>
             <a:endParaRPr lang="en-US" sz="1400" dirty="0"/>
           </a:p>
@@ -4662,7 +4662,7 @@
                 <a:ea typeface="Calibri" pitchFamily="34" charset="-122"/>
                 <a:cs typeface="Calibri" pitchFamily="34" charset="-120"/>
               </a:rPr>
-              <a:t>Play Store 3,033 · App Store 339, across 5 quick-commerce apps</a:t>
+              <a:t>Of 5,898 collected across 11 apps; the rest are not yet gated</a:t>
             </a:r>
             <a:endParaRPr lang="en-US" sz="1400" dirty="0"/>
           </a:p>
@@ -5410,7 +5410,7 @@
                   </a:extLst>
                 </a:hlinkClick>
               </a:rPr>
-              <a:t>Corpus is app-store review text only — Play Store 3,033 · App Store 339.</a:t>
+              <a:t>App-store review text only. 5,898 collected; the figures here describe the 3,372 analysed.</a:t>
             </a:r>
             <a:endParaRPr lang="en-US" sz="1400" dirty="0"/>
           </a:p>

</xml_diff>